<commit_message>
build(pc2): publicar aportes y documentos con códigos oficiales y evidencias
</commit_message>
<xml_diff>
--- a/presentacion/PC2-TriageVoz-Rural-Grupo10.pptx
+++ b/presentacion/PC2-TriageVoz-Rural-Grupo10.pptx
@@ -1996,7 +1996,7 @@
                 <a:ea typeface="Aptos" pitchFamily="34" charset="-122"/>
                 <a:cs typeface="Aptos" pitchFamily="34" charset="-120"/>
               </a:rPr>
-              <a:t>López Arteaga, César Omar — 20236743A</a:t>
+              <a:t>López Arteaga, César Omar — 20215508C</a:t>
             </a:r>
             <a:endParaRPr lang="en-US" sz="1900" dirty="0"/>
           </a:p>
@@ -6831,7 +6831,7 @@
                 <a:ea typeface="Aptos" pitchFamily="34" charset="-122"/>
                 <a:cs typeface="Aptos" pitchFamily="34" charset="-120"/>
               </a:rPr>
-              <a:t>• Capturas actualizadas y video de sustentación de cada integrante.</a:t>
+              <a:t>• Capturas verificables disponibles; video personal de sustentación pendiente.</a:t>
             </a:r>
             <a:endParaRPr lang="en-US" sz="1800" dirty="0"/>
           </a:p>

</xml_diff>